<commit_message>
Add slide 15 - Project Plan (MoSCoW backlog)
Closing slide, both formats. MoSCoW-prioritized: manage costs/profits
(must have - already built as Round 1 core), tax savings advisor bot
(should have), rental contract generation + tenant complaints
management (could have, both adjacent to existing built capabilities),
direct bank connections (nice to have - despite already being the most
technically de-risked item, via the Enable Banking Mock ASPSP demo).

The deliberate point of the slide: technical readiness and customer
priority are different axes - bank connections are furthest along
technically and lowest priority for this customer, which is evidence
the roadmap follows the persona (slide 04) rather than chasing what
was fun to build.

Co-Authored-By: Claude Sonnet 5 <noreply@anthropic.com>
</commit_message>
<xml_diff>
--- a/presentation/slides.pptx
+++ b/presentation/slides.pptx
@@ -19,6 +19,7 @@
     <p:sldId id="267" r:id="rId18"/>
     <p:sldId id="268" r:id="rId19"/>
     <p:sldId id="269" r:id="rId20"/>
+    <p:sldId id="270" r:id="rId21"/>
   </p:sldIdLst>
   <p:sldSz cx="12191695" cy="6858000" type="screen4x3"/>
   <p:notesSz cx="6858000" cy="9144000"/>
@@ -3314,7 +3315,7 @@
                 </a:solidFill>
                 <a:latin typeface="IBM Plex Mono"/>
               </a:rPr>
-              <a:t>01 / 14</a:t>
+              <a:t>01 / 15</a:t>
             </a:r>
           </a:p>
         </p:txBody>
@@ -3703,7 +3704,7 @@
                 </a:solidFill>
                 <a:latin typeface="IBM Plex Mono"/>
               </a:rPr>
-              <a:t>10 / 14</a:t>
+              <a:t>10 / 15</a:t>
             </a:r>
           </a:p>
         </p:txBody>
@@ -4065,7 +4066,7 @@
                 </a:solidFill>
                 <a:latin typeface="IBM Plex Mono"/>
               </a:rPr>
-              <a:t>11 / 14</a:t>
+              <a:t>11 / 15</a:t>
             </a:r>
           </a:p>
         </p:txBody>
@@ -4402,7 +4403,7 @@
                 </a:solidFill>
                 <a:latin typeface="IBM Plex Mono"/>
               </a:rPr>
-              <a:t>12 / 14</a:t>
+              <a:t>12 / 15</a:t>
             </a:r>
           </a:p>
         </p:txBody>
@@ -5202,7 +5203,7 @@
                 </a:solidFill>
                 <a:latin typeface="IBM Plex Mono"/>
               </a:rPr>
-              <a:t>13 / 14</a:t>
+              <a:t>13 / 15</a:t>
             </a:r>
           </a:p>
         </p:txBody>
@@ -6042,7 +6043,729 @@
                 </a:solidFill>
                 <a:latin typeface="IBM Plex Mono"/>
               </a:rPr>
-              <a:t>14 / 14</a:t>
+              <a:t>14 / 15</a:t>
+            </a:r>
+          </a:p>
+        </p:txBody>
+      </p:sp>
+    </p:spTree>
+  </p:cSld>
+  <p:clrMapOvr>
+    <a:masterClrMapping/>
+  </p:clrMapOvr>
+</p:sld>
+</file>
+
+<file path=ppt/slides/slide15.xml><?xml version="1.0" encoding="utf-8"?>
+<p:sld xmlns:a="http://schemas.openxmlformats.org/drawingml/2006/main" xmlns:p="http://schemas.openxmlformats.org/presentationml/2006/main" xmlns:r="http://schemas.openxmlformats.org/officeDocument/2006/relationships">
+  <p:cSld>
+    <p:bg>
+      <p:bgPr>
+        <a:solidFill>
+          <a:srgbClr val="ECEFE2"/>
+        </a:solidFill>
+        <a:effectLst/>
+      </p:bgPr>
+    </p:bg>
+    <p:spTree>
+      <p:nvGrpSpPr>
+        <p:cNvPr id="1" name=""/>
+        <p:cNvGrpSpPr/>
+        <p:nvPr/>
+      </p:nvGrpSpPr>
+      <p:grpSpPr/>
+      <p:sp>
+        <p:nvSpPr>
+          <p:cNvPr id="2" name="TextBox 1"/>
+          <p:cNvSpPr txBox="1"/>
+          <p:nvPr/>
+        </p:nvSpPr>
+        <p:spPr>
+          <a:xfrm>
+            <a:off x="1097280" y="411480"/>
+            <a:ext cx="9144000" cy="365760"/>
+          </a:xfrm>
+          <a:prstGeom prst="rect">
+            <a:avLst/>
+          </a:prstGeom>
+          <a:noFill/>
+        </p:spPr>
+        <p:txBody>
+          <a:bodyPr wrap="none">
+            <a:spAutoFit/>
+          </a:bodyPr>
+          <a:lstStyle/>
+          <a:p>
+            <a:r>
+              <a:rPr sz="1100" b="1" i="0">
+                <a:solidFill>
+                  <a:srgbClr val="1F5E56"/>
+                </a:solidFill>
+                <a:latin typeface="IBM Plex Mono"/>
+              </a:rPr>
+              <a:t>PROJECT PLAN</a:t>
+            </a:r>
+          </a:p>
+        </p:txBody>
+      </p:sp>
+      <p:sp>
+        <p:nvSpPr>
+          <p:cNvPr id="3" name="Rectangle 2"/>
+          <p:cNvSpPr/>
+          <p:nvPr/>
+        </p:nvSpPr>
+        <p:spPr>
+          <a:xfrm>
+            <a:off x="640080" y="384048"/>
+            <a:ext cx="384048" cy="256032"/>
+          </a:xfrm>
+          <a:prstGeom prst="rect">
+            <a:avLst/>
+          </a:prstGeom>
+          <a:solidFill>
+            <a:srgbClr val="1F5E56"/>
+          </a:solidFill>
+          <a:ln>
+            <a:noFill/>
+          </a:ln>
+        </p:spPr>
+        <p:style>
+          <a:lnRef idx="1">
+            <a:schemeClr val="accent1"/>
+          </a:lnRef>
+          <a:fillRef idx="3">
+            <a:schemeClr val="accent1"/>
+          </a:fillRef>
+          <a:effectRef idx="2">
+            <a:schemeClr val="accent1"/>
+          </a:effectRef>
+          <a:fontRef idx="minor">
+            <a:schemeClr val="lt1"/>
+          </a:fontRef>
+        </p:style>
+        <p:txBody>
+          <a:bodyPr rtlCol="0" anchor="ctr" lIns="0" rIns="0" tIns="0"/>
+          <a:lstStyle/>
+          <a:p>
+            <a:pPr algn="ctr"/>
+            <a:r>
+              <a:rPr sz="1000" b="1" i="0">
+                <a:solidFill>
+                  <a:srgbClr val="ECEFE2"/>
+                </a:solidFill>
+                <a:latin typeface="IBM Plex Mono"/>
+              </a:rPr>
+              <a:t>15</a:t>
+            </a:r>
+          </a:p>
+        </p:txBody>
+      </p:sp>
+      <p:sp>
+        <p:nvSpPr>
+          <p:cNvPr id="4" name="TextBox 3"/>
+          <p:cNvSpPr txBox="1"/>
+          <p:nvPr/>
+        </p:nvSpPr>
+        <p:spPr>
+          <a:xfrm>
+            <a:off x="640080" y="777240"/>
+            <a:ext cx="9601200" cy="1463040"/>
+          </a:xfrm>
+          <a:prstGeom prst="rect">
+            <a:avLst/>
+          </a:prstGeom>
+          <a:noFill/>
+        </p:spPr>
+        <p:txBody>
+          <a:bodyPr wrap="square" anchor="t">
+            <a:spAutoFit/>
+          </a:bodyPr>
+          <a:lstStyle/>
+          <a:p>
+            <a:pPr algn="l"/>
+            <a:r>
+              <a:rPr sz="2800" b="1" i="0">
+                <a:solidFill>
+                  <a:srgbClr val="1B2A2E"/>
+                </a:solidFill>
+                <a:latin typeface="IBM Plex Sans"/>
+              </a:rPr>
+              <a:t>What ships when — priority follows the customer, not the demo.</a:t>
+            </a:r>
+          </a:p>
+        </p:txBody>
+      </p:sp>
+      <p:sp>
+        <p:nvSpPr>
+          <p:cNvPr id="5" name="TextBox 4"/>
+          <p:cNvSpPr txBox="1"/>
+          <p:nvPr/>
+        </p:nvSpPr>
+        <p:spPr>
+          <a:xfrm>
+            <a:off x="640080" y="1691640"/>
+            <a:ext cx="10515600" cy="822960"/>
+          </a:xfrm>
+          <a:prstGeom prst="rect">
+            <a:avLst/>
+          </a:prstGeom>
+          <a:noFill/>
+        </p:spPr>
+        <p:txBody>
+          <a:bodyPr wrap="square" anchor="t">
+            <a:spAutoFit/>
+          </a:bodyPr>
+          <a:lstStyle/>
+          <a:p>
+            <a:pPr algn="l"/>
+            <a:r>
+              <a:rPr sz="1450" b="0" i="0">
+                <a:solidFill>
+                  <a:srgbClr val="1B2A2E"/>
+                </a:solidFill>
+                <a:latin typeface="IBM Plex Sans"/>
+              </a:rPr>
+              <a:t>Scoped as a MoSCoW backlog. The order isn't about what's technically impressive — it's about what the landlord from slide 04 (small portfolio, side income, low tech-sophistication) actually needs first.</a:t>
+            </a:r>
+          </a:p>
+        </p:txBody>
+      </p:sp>
+      <p:graphicFrame>
+        <p:nvGraphicFramePr>
+          <p:cNvPr id="6" name="Table 5"/>
+          <p:cNvGraphicFramePr>
+            <a:graphicFrameLocks noGrp="1"/>
+          </p:cNvGraphicFramePr>
+          <p:nvPr/>
+        </p:nvGraphicFramePr>
+        <p:xfrm>
+          <a:off x="640080" y="2743200"/>
+          <a:ext cx="10515600" cy="2743200"/>
+        </p:xfrm>
+        <a:graphic>
+          <a:graphicData uri="http://schemas.openxmlformats.org/drawingml/2006/table">
+            <a:tbl>
+              <a:tblPr firstRow="1" bandRow="1">
+                <a:tableStyleId>{5C22544A-7EE6-4342-B048-85BDC9FD1C3A}</a:tableStyleId>
+              </a:tblPr>
+              <a:tblGrid>
+                <a:gridCol w="1463040"/>
+                <a:gridCol w="3108960"/>
+                <a:gridCol w="5943600"/>
+              </a:tblGrid>
+              <a:tr h="457200">
+                <a:tc>
+                  <a:txBody>
+                    <a:bodyPr/>
+                    <a:lstStyle/>
+                    <a:p>
+                      <a:r>
+                        <a:rPr sz="1100" b="1">
+                          <a:solidFill>
+                            <a:srgbClr val="5B665F"/>
+                          </a:solidFill>
+                          <a:latin typeface="IBM Plex Mono"/>
+                        </a:rPr>
+                        <a:t>Priority</a:t>
+                      </a:r>
+                    </a:p>
+                  </a:txBody>
+                  <a:tcPr>
+                    <a:solidFill>
+                      <a:srgbClr val="F5F6EC"/>
+                    </a:solidFill>
+                  </a:tcPr>
+                </a:tc>
+                <a:tc>
+                  <a:txBody>
+                    <a:bodyPr/>
+                    <a:lstStyle/>
+                    <a:p>
+                      <a:r>
+                        <a:rPr sz="1100" b="1">
+                          <a:solidFill>
+                            <a:srgbClr val="5B665F"/>
+                          </a:solidFill>
+                          <a:latin typeface="IBM Plex Mono"/>
+                        </a:rPr>
+                        <a:t>Feature</a:t>
+                      </a:r>
+                    </a:p>
+                  </a:txBody>
+                  <a:tcPr>
+                    <a:solidFill>
+                      <a:srgbClr val="F5F6EC"/>
+                    </a:solidFill>
+                  </a:tcPr>
+                </a:tc>
+                <a:tc>
+                  <a:txBody>
+                    <a:bodyPr/>
+                    <a:lstStyle/>
+                    <a:p>
+                      <a:r>
+                        <a:rPr sz="1100" b="1">
+                          <a:solidFill>
+                            <a:srgbClr val="5B665F"/>
+                          </a:solidFill>
+                          <a:latin typeface="IBM Plex Mono"/>
+                        </a:rPr>
+                        <a:t>Status</a:t>
+                      </a:r>
+                    </a:p>
+                  </a:txBody>
+                  <a:tcPr>
+                    <a:solidFill>
+                      <a:srgbClr val="F5F6EC"/>
+                    </a:solidFill>
+                  </a:tcPr>
+                </a:tc>
+              </a:tr>
+              <a:tr h="457200">
+                <a:tc>
+                  <a:txBody>
+                    <a:bodyPr/>
+                    <a:lstStyle/>
+                    <a:p>
+                      <a:r>
+                        <a:rPr sz="1300">
+                          <a:solidFill>
+                            <a:srgbClr val="1B2A2E"/>
+                          </a:solidFill>
+                          <a:latin typeface="IBM Plex Mono"/>
+                        </a:rPr>
+                        <a:t>Must have</a:t>
+                      </a:r>
+                    </a:p>
+                  </a:txBody>
+                  <a:tcPr>
+                    <a:solidFill>
+                      <a:srgbClr val="ECEFE2"/>
+                    </a:solidFill>
+                  </a:tcPr>
+                </a:tc>
+                <a:tc>
+                  <a:txBody>
+                    <a:bodyPr/>
+                    <a:lstStyle/>
+                    <a:p>
+                      <a:r>
+                        <a:rPr sz="1300">
+                          <a:solidFill>
+                            <a:srgbClr val="1B2A2E"/>
+                          </a:solidFill>
+                          <a:latin typeface="IBM Plex Mono"/>
+                        </a:rPr>
+                        <a:t>Manage the costs &amp; profits</a:t>
+                      </a:r>
+                    </a:p>
+                  </a:txBody>
+                  <a:tcPr>
+                    <a:solidFill>
+                      <a:srgbClr val="ECEFE2"/>
+                    </a:solidFill>
+                  </a:tcPr>
+                </a:tc>
+                <a:tc>
+                  <a:txBody>
+                    <a:bodyPr/>
+                    <a:lstStyle/>
+                    <a:p>
+                      <a:r>
+                        <a:rPr sz="1300">
+                          <a:solidFill>
+                            <a:srgbClr val="1B2A2E"/>
+                          </a:solidFill>
+                          <a:latin typeface="IBM Plex Mono"/>
+                        </a:rPr>
+                        <a:t>Built - Round 1 core (extraction + dashboard); Round 2 hardens to production</a:t>
+                      </a:r>
+                    </a:p>
+                  </a:txBody>
+                  <a:tcPr>
+                    <a:solidFill>
+                      <a:srgbClr val="ECEFE2"/>
+                    </a:solidFill>
+                  </a:tcPr>
+                </a:tc>
+              </a:tr>
+              <a:tr h="457200">
+                <a:tc>
+                  <a:txBody>
+                    <a:bodyPr/>
+                    <a:lstStyle/>
+                    <a:p>
+                      <a:r>
+                        <a:rPr sz="1300">
+                          <a:solidFill>
+                            <a:srgbClr val="1B2A2E"/>
+                          </a:solidFill>
+                          <a:latin typeface="IBM Plex Mono"/>
+                        </a:rPr>
+                        <a:t>Should have</a:t>
+                      </a:r>
+                    </a:p>
+                  </a:txBody>
+                  <a:tcPr>
+                    <a:solidFill>
+                      <a:srgbClr val="ECEFE2"/>
+                    </a:solidFill>
+                  </a:tcPr>
+                </a:tc>
+                <a:tc>
+                  <a:txBody>
+                    <a:bodyPr/>
+                    <a:lstStyle/>
+                    <a:p>
+                      <a:r>
+                        <a:rPr sz="1300">
+                          <a:solidFill>
+                            <a:srgbClr val="1B2A2E"/>
+                          </a:solidFill>
+                          <a:latin typeface="IBM Plex Mono"/>
+                        </a:rPr>
+                        <a:t>Tax savings advisor bot</a:t>
+                      </a:r>
+                    </a:p>
+                  </a:txBody>
+                  <a:tcPr>
+                    <a:solidFill>
+                      <a:srgbClr val="ECEFE2"/>
+                    </a:solidFill>
+                  </a:tcPr>
+                </a:tc>
+                <a:tc>
+                  <a:txBody>
+                    <a:bodyPr/>
+                    <a:lstStyle/>
+                    <a:p>
+                      <a:r>
+                        <a:rPr sz="1300">
+                          <a:solidFill>
+                            <a:srgbClr val="1B2A2E"/>
+                          </a:solidFill>
+                          <a:latin typeface="IBM Plex Mono"/>
+                        </a:rPr>
+                        <a:t>New - Round 2/3 candidate</a:t>
+                      </a:r>
+                    </a:p>
+                  </a:txBody>
+                  <a:tcPr>
+                    <a:solidFill>
+                      <a:srgbClr val="ECEFE2"/>
+                    </a:solidFill>
+                  </a:tcPr>
+                </a:tc>
+              </a:tr>
+              <a:tr h="457200">
+                <a:tc>
+                  <a:txBody>
+                    <a:bodyPr/>
+                    <a:lstStyle/>
+                    <a:p>
+                      <a:r>
+                        <a:rPr sz="1300">
+                          <a:solidFill>
+                            <a:srgbClr val="1B2A2E"/>
+                          </a:solidFill>
+                          <a:latin typeface="IBM Plex Mono"/>
+                        </a:rPr>
+                        <a:t>Could have</a:t>
+                      </a:r>
+                    </a:p>
+                  </a:txBody>
+                  <a:tcPr>
+                    <a:solidFill>
+                      <a:srgbClr val="ECEFE2"/>
+                    </a:solidFill>
+                  </a:tcPr>
+                </a:tc>
+                <a:tc>
+                  <a:txBody>
+                    <a:bodyPr/>
+                    <a:lstStyle/>
+                    <a:p>
+                      <a:r>
+                        <a:rPr sz="1300">
+                          <a:solidFill>
+                            <a:srgbClr val="1B2A2E"/>
+                          </a:solidFill>
+                          <a:latin typeface="IBM Plex Mono"/>
+                        </a:rPr>
+                        <a:t>Automated rental contract generation</a:t>
+                      </a:r>
+                    </a:p>
+                  </a:txBody>
+                  <a:tcPr>
+                    <a:solidFill>
+                      <a:srgbClr val="ECEFE2"/>
+                    </a:solidFill>
+                  </a:tcPr>
+                </a:tc>
+                <a:tc>
+                  <a:txBody>
+                    <a:bodyPr/>
+                    <a:lstStyle/>
+                    <a:p>
+                      <a:r>
+                        <a:rPr sz="1300">
+                          <a:solidFill>
+                            <a:srgbClr val="1B2A2E"/>
+                          </a:solidFill>
+                          <a:latin typeface="IBM Plex Mono"/>
+                        </a:rPr>
+                        <a:t>Adjacent to lease-extraction already built - inverse direction</a:t>
+                      </a:r>
+                    </a:p>
+                  </a:txBody>
+                  <a:tcPr>
+                    <a:solidFill>
+                      <a:srgbClr val="ECEFE2"/>
+                    </a:solidFill>
+                  </a:tcPr>
+                </a:tc>
+              </a:tr>
+              <a:tr h="457200">
+                <a:tc>
+                  <a:txBody>
+                    <a:bodyPr/>
+                    <a:lstStyle/>
+                    <a:p>
+                      <a:r>
+                        <a:rPr sz="1300">
+                          <a:solidFill>
+                            <a:srgbClr val="1B2A2E"/>
+                          </a:solidFill>
+                          <a:latin typeface="IBM Plex Mono"/>
+                        </a:rPr>
+                        <a:t>Could have</a:t>
+                      </a:r>
+                    </a:p>
+                  </a:txBody>
+                  <a:tcPr>
+                    <a:solidFill>
+                      <a:srgbClr val="ECEFE2"/>
+                    </a:solidFill>
+                  </a:tcPr>
+                </a:tc>
+                <a:tc>
+                  <a:txBody>
+                    <a:bodyPr/>
+                    <a:lstStyle/>
+                    <a:p>
+                      <a:r>
+                        <a:rPr sz="1300">
+                          <a:solidFill>
+                            <a:srgbClr val="1B2A2E"/>
+                          </a:solidFill>
+                          <a:latin typeface="IBM Plex Mono"/>
+                        </a:rPr>
+                        <a:t>Tenant complaints management</a:t>
+                      </a:r>
+                    </a:p>
+                  </a:txBody>
+                  <a:tcPr>
+                    <a:solidFill>
+                      <a:srgbClr val="ECEFE2"/>
+                    </a:solidFill>
+                  </a:tcPr>
+                </a:tc>
+                <a:tc>
+                  <a:txBody>
+                    <a:bodyPr/>
+                    <a:lstStyle/>
+                    <a:p>
+                      <a:r>
+                        <a:rPr sz="1300">
+                          <a:solidFill>
+                            <a:srgbClr val="1B2A2E"/>
+                          </a:solidFill>
+                          <a:latin typeface="IBM Plex Mono"/>
+                        </a:rPr>
+                        <a:t>Adjacent to maintenance-request tracking already prototyped</a:t>
+                      </a:r>
+                    </a:p>
+                  </a:txBody>
+                  <a:tcPr>
+                    <a:solidFill>
+                      <a:srgbClr val="ECEFE2"/>
+                    </a:solidFill>
+                  </a:tcPr>
+                </a:tc>
+              </a:tr>
+              <a:tr h="457200">
+                <a:tc>
+                  <a:txBody>
+                    <a:bodyPr/>
+                    <a:lstStyle/>
+                    <a:p>
+                      <a:r>
+                        <a:rPr sz="1300">
+                          <a:solidFill>
+                            <a:srgbClr val="1B2A2E"/>
+                          </a:solidFill>
+                          <a:latin typeface="IBM Plex Mono"/>
+                        </a:rPr>
+                        <a:t>Nice to have</a:t>
+                      </a:r>
+                    </a:p>
+                  </a:txBody>
+                  <a:tcPr>
+                    <a:solidFill>
+                      <a:srgbClr val="ECEFE2"/>
+                    </a:solidFill>
+                  </a:tcPr>
+                </a:tc>
+                <a:tc>
+                  <a:txBody>
+                    <a:bodyPr/>
+                    <a:lstStyle/>
+                    <a:p>
+                      <a:r>
+                        <a:rPr sz="1300">
+                          <a:solidFill>
+                            <a:srgbClr val="1B2A2E"/>
+                          </a:solidFill>
+                          <a:latin typeface="IBM Plex Mono"/>
+                        </a:rPr>
+                        <a:t>Direct bank connections (rent verification, tenant reminders, auto statement pull)</a:t>
+                      </a:r>
+                    </a:p>
+                  </a:txBody>
+                  <a:tcPr>
+                    <a:solidFill>
+                      <a:srgbClr val="ECEFE2"/>
+                    </a:solidFill>
+                  </a:tcPr>
+                </a:tc>
+                <a:tc>
+                  <a:txBody>
+                    <a:bodyPr/>
+                    <a:lstStyle/>
+                    <a:p>
+                      <a:r>
+                        <a:rPr sz="1300">
+                          <a:solidFill>
+                            <a:srgbClr val="1B2A2E"/>
+                          </a:solidFill>
+                          <a:latin typeface="IBM Plex Mono"/>
+                        </a:rPr>
+                        <a:t>Already demoed end to end (Enable Banking Mock ASPSP) - lowest priority, most de-risked</a:t>
+                      </a:r>
+                    </a:p>
+                  </a:txBody>
+                  <a:tcPr>
+                    <a:solidFill>
+                      <a:srgbClr val="ECEFE2"/>
+                    </a:solidFill>
+                  </a:tcPr>
+                </a:tc>
+              </a:tr>
+            </a:tbl>
+          </a:graphicData>
+        </a:graphic>
+      </p:graphicFrame>
+      <p:sp>
+        <p:nvSpPr>
+          <p:cNvPr id="7" name="TextBox 6"/>
+          <p:cNvSpPr txBox="1"/>
+          <p:nvPr/>
+        </p:nvSpPr>
+        <p:spPr>
+          <a:xfrm>
+            <a:off x="640080" y="5623560"/>
+            <a:ext cx="10515600" cy="914400"/>
+          </a:xfrm>
+          <a:prstGeom prst="rect">
+            <a:avLst/>
+          </a:prstGeom>
+          <a:noFill/>
+        </p:spPr>
+        <p:txBody>
+          <a:bodyPr wrap="square" anchor="t">
+            <a:spAutoFit/>
+          </a:bodyPr>
+          <a:lstStyle/>
+          <a:p>
+            <a:pPr algn="l"/>
+            <a:r>
+              <a:rPr sz="1300" b="0" i="1">
+                <a:solidFill>
+                  <a:srgbClr val="1B2A2E"/>
+                </a:solidFill>
+                <a:latin typeface="IBM Plex Sans"/>
+              </a:rPr>
+              <a:t>That last row is deliberate: technical readiness and customer priority aren't the same axis. Bank connections are the furthest along technically and the lowest priority for this customer - proof the roadmap follows the persona (slide 04), not the excitement of what got built.</a:t>
+            </a:r>
+          </a:p>
+        </p:txBody>
+      </p:sp>
+      <p:sp>
+        <p:nvSpPr>
+          <p:cNvPr id="8" name="TextBox 7"/>
+          <p:cNvSpPr txBox="1"/>
+          <p:nvPr/>
+        </p:nvSpPr>
+        <p:spPr>
+          <a:xfrm>
+            <a:off x="640080" y="6492240"/>
+            <a:ext cx="3657600" cy="274320"/>
+          </a:xfrm>
+          <a:prstGeom prst="rect">
+            <a:avLst/>
+          </a:prstGeom>
+          <a:noFill/>
+        </p:spPr>
+        <p:txBody>
+          <a:bodyPr wrap="square" anchor="t">
+            <a:spAutoFit/>
+          </a:bodyPr>
+          <a:lstStyle/>
+          <a:p>
+            <a:pPr algn="l"/>
+            <a:r>
+              <a:rPr sz="950" b="0" i="0">
+                <a:solidFill>
+                  <a:srgbClr val="5B665F"/>
+                </a:solidFill>
+                <a:latin typeface="IBM Plex Mono"/>
+              </a:rPr>
+              <a:t>Property Ledger</a:t>
+            </a:r>
+          </a:p>
+        </p:txBody>
+      </p:sp>
+      <p:sp>
+        <p:nvSpPr>
+          <p:cNvPr id="9" name="TextBox 8"/>
+          <p:cNvSpPr txBox="1"/>
+          <p:nvPr/>
+        </p:nvSpPr>
+        <p:spPr>
+          <a:xfrm>
+            <a:off x="10789920" y="6492240"/>
+            <a:ext cx="914400" cy="274320"/>
+          </a:xfrm>
+          <a:prstGeom prst="rect">
+            <a:avLst/>
+          </a:prstGeom>
+          <a:noFill/>
+        </p:spPr>
+        <p:txBody>
+          <a:bodyPr wrap="square" anchor="t">
+            <a:spAutoFit/>
+          </a:bodyPr>
+          <a:lstStyle/>
+          <a:p>
+            <a:pPr algn="r"/>
+            <a:r>
+              <a:rPr sz="950" b="0" i="0">
+                <a:solidFill>
+                  <a:srgbClr val="5B665F"/>
+                </a:solidFill>
+                <a:latin typeface="IBM Plex Mono"/>
+              </a:rPr>
+              <a:t>15 / 15</a:t>
             </a:r>
           </a:p>
         </p:txBody>
@@ -6434,7 +7157,7 @@
                 </a:solidFill>
                 <a:latin typeface="IBM Plex Mono"/>
               </a:rPr>
-              <a:t>02 / 14</a:t>
+              <a:t>02 / 15</a:t>
             </a:r>
           </a:p>
         </p:txBody>
@@ -7026,7 +7749,7 @@
                 </a:solidFill>
                 <a:latin typeface="IBM Plex Mono"/>
               </a:rPr>
-              <a:t>03 / 14</a:t>
+              <a:t>03 / 15</a:t>
             </a:r>
           </a:p>
         </p:txBody>
@@ -7483,7 +8206,7 @@
                 </a:solidFill>
                 <a:latin typeface="IBM Plex Mono"/>
               </a:rPr>
-              <a:t>04 / 14</a:t>
+              <a:t>04 / 15</a:t>
             </a:r>
           </a:p>
         </p:txBody>
@@ -8075,7 +8798,7 @@
                 </a:solidFill>
                 <a:latin typeface="IBM Plex Mono"/>
               </a:rPr>
-              <a:t>05 / 14</a:t>
+              <a:t>05 / 15</a:t>
             </a:r>
           </a:p>
         </p:txBody>
@@ -8654,7 +9377,7 @@
                 </a:solidFill>
                 <a:latin typeface="IBM Plex Mono"/>
               </a:rPr>
-              <a:t>06 / 14</a:t>
+              <a:t>06 / 15</a:t>
             </a:r>
           </a:p>
         </p:txBody>
@@ -9453,7 +10176,7 @@
                 </a:solidFill>
                 <a:latin typeface="IBM Plex Mono"/>
               </a:rPr>
-              <a:t>07 / 14</a:t>
+              <a:t>07 / 15</a:t>
             </a:r>
           </a:p>
         </p:txBody>
@@ -10031,7 +10754,7 @@
                 </a:solidFill>
                 <a:latin typeface="IBM Plex Mono"/>
               </a:rPr>
-              <a:t>08 / 14</a:t>
+              <a:t>08 / 15</a:t>
             </a:r>
           </a:p>
         </p:txBody>
@@ -10688,7 +11411,7 @@
                 </a:solidFill>
                 <a:latin typeface="IBM Plex Mono"/>
               </a:rPr>
-              <a:t>09 / 14</a:t>
+              <a:t>09 / 15</a:t>
             </a:r>
           </a:p>
         </p:txBody>

</xml_diff>